<commit_message>
Use training placeholder details in CRM and dashboard screenshots
Replace the blurred customer details with sample data (name, email,
phone, address) and swap cleaner photos for cartoon avatars.

Co-Authored-By: Claude Opus 5.5 <noreply@anthropic.com>
Claude-Session: https://claude.ai/code/session_01FEzv8wwqWDgTsXP8Yz6XYn
</commit_message>
<xml_diff>
--- a/customer-foundations/customer-foundations-c-crm.pptx
+++ b/customer-foundations/customer-foundations-c-crm.pptx
@@ -1411,7 +1411,7 @@
           <a:p>
             <a:r>
               <a:rPr lang="en-US" dirty="0"/>
-              <a:t>The CRM is the central hub for managing customer and cleaner accounts, jobs and payments. It is also where we communicate with users, manage tickets, see our daily targets, and access the information that helps us handle users' concerns. We currently have two CRM systems; we introduce the Legacy CRM first. The screenshot is only a preview; the trainer will walk through the live system next. Customer details in the screenshot are blurred on purpose (see ZTP: work screens).</a:t>
+              <a:t>The CRM is the central hub for managing customer and cleaner accounts, jobs and payments. It is also where we communicate with users, manage tickets, see our daily targets, and access the information that helps us handle users' concerns. We currently have two CRM systems; we introduce the Legacy CRM first. The screenshot is only a preview; the trainer will walk through the live system next. Customer details in the screenshot are sample training data, not a real customer.</a:t>
             </a:r>
             <a:endParaRPr lang="en-US" dirty="0"/>
           </a:p>
@@ -1763,7 +1763,7 @@
           <a:p>
             <a:r>
               <a:rPr lang="en-US" dirty="0"/>
-              <a:t>The Customer dashboard is where customers manage their account and bookings: book a cleaning, see upcoming and past cleanings and alerts (e.g. a cancelled cleaning), and, up to 6 hours before start, reschedule, cancel or match with a different cleaner. Knowing what they see lets agents point customers to self-serve steps and understand what they have already tried. Customer name and cleaner photos in the screenshot are blurred.</a:t>
+              <a:t>The Customer dashboard is where customers manage their account and bookings: book a cleaning, see upcoming and past cleanings and alerts (e.g. a cancelled cleaning), and, up to 6 hours before start, reschedule, cancel or match with a different cleaner. Knowing what they see lets agents point customers to self-serve steps and understand what they have already tried. Customer details and cleaner photos in the screenshot are training placeholders.</a:t>
             </a:r>
             <a:endParaRPr lang="en-US" dirty="0"/>
           </a:p>
@@ -2027,7 +2027,7 @@
           <a:p>
             <a:r>
               <a:rPr lang="en-US" dirty="0"/>
-              <a:t>The New C CRM is where we respond to customers. The screenshot is a preview of a ticket: ticket header, customer information, related jobs, and the message thread with the reply box. Customer details are blurred. The trainer walks through the live system next.</a:t>
+              <a:t>The New C CRM is where we respond to customers. The screenshot is a preview of a ticket: ticket header, customer information, related jobs, and the message thread with the reply box. Customer details are sample training data. The trainer walks through the live system next.</a:t>
             </a:r>
             <a:endParaRPr lang="en-US" dirty="0"/>
           </a:p>
@@ -13634,7 +13634,7 @@
                 <a:ea typeface="SF Pro Text" pitchFamily="34" charset="-122"/>
                 <a:cs typeface="SF Pro Text" pitchFamily="34" charset="-120"/>
               </a:rPr>
-              <a:t>Legacy C CRM, preview only. Customer details blurred.</a:t>
+              <a:t>Legacy C CRM, preview only. Sample training details.</a:t>
             </a:r>
             <a:endParaRPr lang="en-US" sz="800" dirty="0"/>
           </a:p>
@@ -17840,7 +17840,7 @@
                 <a:ea typeface="SF Pro Text" pitchFamily="34" charset="-122"/>
                 <a:cs typeface="SF Pro Text" pitchFamily="34" charset="-120"/>
               </a:rPr>
-              <a:t>C Dashboard, preview only. Customer details blurred.</a:t>
+              <a:t>C Dashboard, preview only. Sample training details.</a:t>
             </a:r>
             <a:endParaRPr lang="en-US" sz="800" dirty="0"/>
           </a:p>
@@ -20383,7 +20383,7 @@
                 <a:ea typeface="SF Pro Text" pitchFamily="34" charset="-122"/>
                 <a:cs typeface="SF Pro Text" pitchFamily="34" charset="-120"/>
               </a:rPr>
-              <a:t>New C CRM, preview only. Customer details blurred.</a:t>
+              <a:t>New C CRM, preview only. Sample training details.</a:t>
             </a:r>
             <a:endParaRPr lang="en-US" sz="800" dirty="0"/>
           </a:p>

</xml_diff>